<commit_message>
SIH26074 deck: GitHub link in the tech stack section
Co-Authored-By: Claude Opus 5.5 <noreply@anthropic.com>
</commit_message>
<xml_diff>
--- a/docs/deck074_v2/SIH26074_FAST_CURIOUS.pptx
+++ b/docs/deck074_v2/SIH26074_FAST_CURIOUS.pptx
@@ -5291,8 +5291,8 @@
         </p:nvSpPr>
         <p:spPr>
           <a:xfrm>
-            <a:off x="177800" y="4953000"/>
-            <a:ext cx="2455333" cy="508000"/>
+            <a:off x="177800" y="4064000"/>
+            <a:ext cx="2455333" cy="254000"/>
           </a:xfrm>
           <a:prstGeom prst="rect">
             <a:avLst/>
@@ -5307,7 +5307,7 @@
           <a:p>
             <a:pPr algn="l">
               <a:lnSpc>
-                <a:spcPct val="92000"/>
+                <a:spcPct val="100000"/>
               </a:lnSpc>
               <a:spcAft>
                 <a:spcPts val="0"/>
@@ -5320,26 +5320,7 @@
                 </a:solidFill>
                 <a:latin typeface="Times New Roman"/>
               </a:rPr>
-              <a:t>PERFORMANCE &amp;</a:t>
-            </a:r>
-          </a:p>
-          <a:p>
-            <a:pPr algn="l">
-              <a:lnSpc>
-                <a:spcPct val="92000"/>
-              </a:lnSpc>
-              <a:spcAft>
-                <a:spcPts val="0"/>
-              </a:spcAft>
-            </a:pPr>
-            <a:r>
-              <a:rPr sz="1466" b="1">
-                <a:solidFill>
-                  <a:srgbClr val="000000"/>
-                </a:solidFill>
-                <a:latin typeface="Times New Roman"/>
-              </a:rPr>
-              <a:t>TESTING</a:t>
+              <a:t>CODE &amp; MODEL WEIGHTS</a:t>
             </a:r>
           </a:p>
         </p:txBody>
@@ -5352,8 +5333,8 @@
         </p:nvSpPr>
         <p:spPr>
           <a:xfrm>
-            <a:off x="254000" y="5418667"/>
-            <a:ext cx="2413000" cy="931333"/>
+            <a:off x="254000" y="4309533"/>
+            <a:ext cx="2413000" cy="592667"/>
           </a:xfrm>
           <a:prstGeom prst="rect">
             <a:avLst/>
@@ -5366,6 +5347,130 @@
           </a:bodyPr>
           <a:lstStyle/>
           <a:p>
+            <a:pPr algn="l">
+              <a:lnSpc>
+                <a:spcPct val="92000"/>
+              </a:lnSpc>
+              <a:spcAft>
+                <a:spcPts val="0"/>
+              </a:spcAft>
+            </a:pPr>
+            <a:r>
+              <a:rPr sz="1266" b="0" u="sng">
+                <a:solidFill>
+                  <a:srgbClr val="0E4F8A"/>
+                </a:solidFill>
+                <a:latin typeface="Times New Roman"/>
+                <a:hlinkClick r:id="rId3"/>
+              </a:rPr>
+              <a:t>github.com/rohzhegde26/</a:t>
+            </a:r>
+          </a:p>
+          <a:p>
+            <a:pPr algn="l">
+              <a:lnSpc>
+                <a:spcPct val="92000"/>
+              </a:lnSpc>
+              <a:spcAft>
+                <a:spcPts val="0"/>
+              </a:spcAft>
+            </a:pPr>
+            <a:r>
+              <a:rPr sz="1266" b="0" u="sng">
+                <a:solidFill>
+                  <a:srgbClr val="0E4F8A"/>
+                </a:solidFill>
+                <a:latin typeface="Times New Roman"/>
+                <a:hlinkClick r:id="rId3"/>
+              </a:rPr>
+              <a:t>SIH-26074-Fast-and-Curious</a:t>
+            </a:r>
+          </a:p>
+        </p:txBody>
+      </p:sp>
+      <p:sp>
+        <p:nvSpPr>
+          <p:cNvPr id="12" name="TextBox 11"/>
+          <p:cNvSpPr txBox="1"/>
+          <p:nvPr/>
+        </p:nvSpPr>
+        <p:spPr>
+          <a:xfrm>
+            <a:off x="177800" y="4953000"/>
+            <a:ext cx="2455333" cy="508000"/>
+          </a:xfrm>
+          <a:prstGeom prst="rect">
+            <a:avLst/>
+          </a:prstGeom>
+          <a:noFill/>
+        </p:spPr>
+        <p:txBody>
+          <a:bodyPr wrap="square" lIns="0" rIns="0" tIns="0" bIns="0" anchor="t">
+            <a:spAutoFit/>
+          </a:bodyPr>
+          <a:lstStyle/>
+          <a:p>
+            <a:pPr algn="l">
+              <a:lnSpc>
+                <a:spcPct val="92000"/>
+              </a:lnSpc>
+              <a:spcAft>
+                <a:spcPts val="0"/>
+              </a:spcAft>
+            </a:pPr>
+            <a:r>
+              <a:rPr sz="1466" b="1">
+                <a:solidFill>
+                  <a:srgbClr val="000000"/>
+                </a:solidFill>
+                <a:latin typeface="Times New Roman"/>
+              </a:rPr>
+              <a:t>PERFORMANCE &amp;</a:t>
+            </a:r>
+          </a:p>
+          <a:p>
+            <a:pPr algn="l">
+              <a:lnSpc>
+                <a:spcPct val="92000"/>
+              </a:lnSpc>
+              <a:spcAft>
+                <a:spcPts val="0"/>
+              </a:spcAft>
+            </a:pPr>
+            <a:r>
+              <a:rPr sz="1466" b="1">
+                <a:solidFill>
+                  <a:srgbClr val="000000"/>
+                </a:solidFill>
+                <a:latin typeface="Times New Roman"/>
+              </a:rPr>
+              <a:t>TESTING</a:t>
+            </a:r>
+          </a:p>
+        </p:txBody>
+      </p:sp>
+      <p:sp>
+        <p:nvSpPr>
+          <p:cNvPr id="13" name="TextBox 12"/>
+          <p:cNvSpPr txBox="1"/>
+          <p:nvPr/>
+        </p:nvSpPr>
+        <p:spPr>
+          <a:xfrm>
+            <a:off x="254000" y="5418667"/>
+            <a:ext cx="2413000" cy="931333"/>
+          </a:xfrm>
+          <a:prstGeom prst="rect">
+            <a:avLst/>
+          </a:prstGeom>
+          <a:noFill/>
+        </p:spPr>
+        <p:txBody>
+          <a:bodyPr wrap="square" lIns="0" rIns="0" tIns="0" bIns="0" anchor="t">
+            <a:spAutoFit/>
+          </a:bodyPr>
+          <a:lstStyle/>
+          <a:p>
             <a:pPr algn="l" marL="220133" indent="-186267">
               <a:lnSpc>
                 <a:spcPct val="92000"/>
@@ -5453,7 +5558,7 @@
       </p:sp>
       <p:cxnSp>
         <p:nvCxnSpPr>
-          <p:cNvPr id="12" name="Connector 11"/>
+          <p:cNvPr id="14" name="Connector 13"/>
           <p:cNvCxnSpPr/>
           <p:nvPr/>
         </p:nvCxnSpPr>
@@ -5488,7 +5593,7 @@
       </p:cxnSp>
       <p:sp>
         <p:nvSpPr>
-          <p:cNvPr id="13" name="Rounded Rectangle 12"/>
+          <p:cNvPr id="15" name="Rounded Rectangle 14"/>
           <p:cNvSpPr/>
           <p:nvPr/>
         </p:nvSpPr>
@@ -5534,7 +5639,7 @@
       </p:sp>
       <p:sp>
         <p:nvSpPr>
-          <p:cNvPr id="14" name="TextBox 13"/>
+          <p:cNvPr id="16" name="TextBox 15"/>
           <p:cNvSpPr txBox="1"/>
           <p:nvPr/>
         </p:nvSpPr>
@@ -5576,7 +5681,7 @@
       </p:sp>
       <p:sp>
         <p:nvSpPr>
-          <p:cNvPr id="15" name="Rounded Rectangle 14"/>
+          <p:cNvPr id="17" name="Rounded Rectangle 16"/>
           <p:cNvSpPr/>
           <p:nvPr/>
         </p:nvSpPr>
@@ -5622,14 +5727,14 @@
       </p:sp>
       <p:pic>
         <p:nvPicPr>
-          <p:cNvPr id="16" name="Picture 15" descr="icon_clock.png"/>
+          <p:cNvPr id="18" name="Picture 17" descr="icon_clock.png"/>
           <p:cNvPicPr>
             <a:picLocks noChangeAspect="1"/>
           </p:cNvPicPr>
           <p:nvPr/>
         </p:nvPicPr>
         <p:blipFill>
-          <a:blip r:embed="rId3"/>
+          <a:blip r:embed="rId4"/>
           <a:stretch>
             <a:fillRect/>
           </a:stretch>
@@ -5646,7 +5751,7 @@
       </p:pic>
       <p:sp>
         <p:nvSpPr>
-          <p:cNvPr id="17" name="TextBox 16"/>
+          <p:cNvPr id="19" name="TextBox 18"/>
           <p:cNvSpPr txBox="1"/>
           <p:nvPr/>
         </p:nvSpPr>
@@ -5726,7 +5831,7 @@
       </p:sp>
       <p:sp>
         <p:nvSpPr>
-          <p:cNvPr id="18" name="Rounded Rectangle 17"/>
+          <p:cNvPr id="20" name="Rounded Rectangle 19"/>
           <p:cNvSpPr/>
           <p:nvPr/>
         </p:nvSpPr>
@@ -5772,14 +5877,14 @@
       </p:sp>
       <p:pic>
         <p:nvPicPr>
-          <p:cNvPr id="19" name="Picture 18" descr="icon_sat.png"/>
+          <p:cNvPr id="21" name="Picture 20" descr="icon_sat.png"/>
           <p:cNvPicPr>
             <a:picLocks noChangeAspect="1"/>
           </p:cNvPicPr>
           <p:nvPr/>
         </p:nvPicPr>
         <p:blipFill>
-          <a:blip r:embed="rId4"/>
+          <a:blip r:embed="rId5"/>
           <a:stretch>
             <a:fillRect/>
           </a:stretch>
@@ -5796,7 +5901,7 @@
       </p:pic>
       <p:sp>
         <p:nvSpPr>
-          <p:cNvPr id="20" name="TextBox 19"/>
+          <p:cNvPr id="22" name="TextBox 21"/>
           <p:cNvSpPr txBox="1"/>
           <p:nvPr/>
         </p:nvSpPr>
@@ -5876,7 +5981,7 @@
       </p:sp>
       <p:sp>
         <p:nvSpPr>
-          <p:cNvPr id="21" name="Rounded Rectangle 20"/>
+          <p:cNvPr id="23" name="Rounded Rectangle 22"/>
           <p:cNvSpPr/>
           <p:nvPr/>
         </p:nvSpPr>
@@ -5922,14 +6027,14 @@
       </p:sp>
       <p:pic>
         <p:nvPicPr>
-          <p:cNvPr id="22" name="Picture 21" descr="icon_terrain.png"/>
+          <p:cNvPr id="24" name="Picture 23" descr="icon_terrain.png"/>
           <p:cNvPicPr>
             <a:picLocks noChangeAspect="1"/>
           </p:cNvPicPr>
           <p:nvPr/>
         </p:nvPicPr>
         <p:blipFill>
-          <a:blip r:embed="rId5"/>
+          <a:blip r:embed="rId6"/>
           <a:stretch>
             <a:fillRect/>
           </a:stretch>
@@ -5946,7 +6051,7 @@
       </p:pic>
       <p:sp>
         <p:nvSpPr>
-          <p:cNvPr id="23" name="TextBox 22"/>
+          <p:cNvPr id="25" name="TextBox 24"/>
           <p:cNvSpPr txBox="1"/>
           <p:nvPr/>
         </p:nvSpPr>
@@ -6026,7 +6131,7 @@
       </p:sp>
       <p:sp>
         <p:nvSpPr>
-          <p:cNvPr id="24" name="Rounded Rectangle 23"/>
+          <p:cNvPr id="26" name="Rounded Rectangle 25"/>
           <p:cNvSpPr/>
           <p:nvPr/>
         </p:nvSpPr>
@@ -6072,7 +6177,7 @@
       </p:sp>
       <p:sp>
         <p:nvSpPr>
-          <p:cNvPr id="25" name="TextBox 24"/>
+          <p:cNvPr id="27" name="TextBox 26"/>
           <p:cNvSpPr txBox="1"/>
           <p:nvPr/>
         </p:nvSpPr>
@@ -6227,7 +6332,7 @@
       </p:sp>
       <p:sp>
         <p:nvSpPr>
-          <p:cNvPr id="26" name="Rounded Rectangle 25"/>
+          <p:cNvPr id="28" name="Rounded Rectangle 27"/>
           <p:cNvSpPr/>
           <p:nvPr/>
         </p:nvSpPr>
@@ -6273,7 +6378,7 @@
       </p:sp>
       <p:sp>
         <p:nvSpPr>
-          <p:cNvPr id="27" name="TextBox 26"/>
+          <p:cNvPr id="29" name="TextBox 28"/>
           <p:cNvSpPr txBox="1"/>
           <p:nvPr/>
         </p:nvSpPr>
@@ -6427,7 +6532,7 @@
       </p:sp>
       <p:sp>
         <p:nvSpPr>
-          <p:cNvPr id="28" name="Rounded Rectangle 27"/>
+          <p:cNvPr id="30" name="Rounded Rectangle 29"/>
           <p:cNvSpPr/>
           <p:nvPr/>
         </p:nvSpPr>
@@ -6473,7 +6578,7 @@
       </p:sp>
       <p:sp>
         <p:nvSpPr>
-          <p:cNvPr id="29" name="TextBox 28"/>
+          <p:cNvPr id="31" name="TextBox 30"/>
           <p:cNvSpPr txBox="1"/>
           <p:nvPr/>
         </p:nvSpPr>
@@ -6627,7 +6732,7 @@
       </p:sp>
       <p:sp>
         <p:nvSpPr>
-          <p:cNvPr id="30" name="Rounded Rectangle 29"/>
+          <p:cNvPr id="32" name="Rounded Rectangle 31"/>
           <p:cNvSpPr/>
           <p:nvPr/>
         </p:nvSpPr>
@@ -6673,7 +6778,7 @@
       </p:sp>
       <p:sp>
         <p:nvSpPr>
-          <p:cNvPr id="31" name="TextBox 30"/>
+          <p:cNvPr id="33" name="TextBox 32"/>
           <p:cNvSpPr txBox="1"/>
           <p:nvPr/>
         </p:nvSpPr>
@@ -6867,7 +6972,7 @@
       </p:sp>
       <p:sp>
         <p:nvSpPr>
-          <p:cNvPr id="32" name="Rounded Rectangle 31"/>
+          <p:cNvPr id="34" name="Rounded Rectangle 33"/>
           <p:cNvSpPr/>
           <p:nvPr/>
         </p:nvSpPr>
@@ -6913,7 +7018,7 @@
       </p:sp>
       <p:sp>
         <p:nvSpPr>
-          <p:cNvPr id="33" name="TextBox 32"/>
+          <p:cNvPr id="35" name="TextBox 34"/>
           <p:cNvSpPr txBox="1"/>
           <p:nvPr/>
         </p:nvSpPr>
@@ -7021,7 +7126,7 @@
       </p:sp>
       <p:cxnSp>
         <p:nvCxnSpPr>
-          <p:cNvPr id="34" name="Connector 33"/>
+          <p:cNvPr id="36" name="Connector 35"/>
           <p:cNvCxnSpPr/>
           <p:nvPr/>
         </p:nvCxnSpPr>
@@ -7056,7 +7161,7 @@
       </p:cxnSp>
       <p:cxnSp>
         <p:nvCxnSpPr>
-          <p:cNvPr id="35" name="Connector 34"/>
+          <p:cNvPr id="37" name="Connector 36"/>
           <p:cNvCxnSpPr/>
           <p:nvPr/>
         </p:nvCxnSpPr>
@@ -7092,7 +7197,7 @@
       </p:cxnSp>
       <p:sp>
         <p:nvSpPr>
-          <p:cNvPr id="36" name="Oval 35"/>
+          <p:cNvPr id="38" name="Oval 37"/>
           <p:cNvSpPr/>
           <p:nvPr/>
         </p:nvSpPr>
@@ -7134,7 +7239,7 @@
       </p:sp>
       <p:cxnSp>
         <p:nvCxnSpPr>
-          <p:cNvPr id="37" name="Connector 36"/>
+          <p:cNvPr id="39" name="Connector 38"/>
           <p:cNvCxnSpPr/>
           <p:nvPr/>
         </p:nvCxnSpPr>
@@ -7170,7 +7275,7 @@
       </p:cxnSp>
       <p:sp>
         <p:nvSpPr>
-          <p:cNvPr id="38" name="Oval 37"/>
+          <p:cNvPr id="40" name="Oval 39"/>
           <p:cNvSpPr/>
           <p:nvPr/>
         </p:nvSpPr>
@@ -7212,7 +7317,7 @@
       </p:sp>
       <p:cxnSp>
         <p:nvCxnSpPr>
-          <p:cNvPr id="39" name="Connector 38"/>
+          <p:cNvPr id="41" name="Connector 40"/>
           <p:cNvCxnSpPr/>
           <p:nvPr/>
         </p:nvCxnSpPr>
@@ -7248,7 +7353,7 @@
       </p:cxnSp>
       <p:sp>
         <p:nvSpPr>
-          <p:cNvPr id="40" name="Oval 39"/>
+          <p:cNvPr id="42" name="Oval 41"/>
           <p:cNvSpPr/>
           <p:nvPr/>
         </p:nvSpPr>
@@ -7290,7 +7395,7 @@
       </p:sp>
       <p:cxnSp>
         <p:nvCxnSpPr>
-          <p:cNvPr id="41" name="Connector 40"/>
+          <p:cNvPr id="43" name="Connector 42"/>
           <p:cNvCxnSpPr/>
           <p:nvPr/>
         </p:nvCxnSpPr>
@@ -7326,7 +7431,7 @@
       </p:cxnSp>
       <p:cxnSp>
         <p:nvCxnSpPr>
-          <p:cNvPr id="42" name="Connector 41"/>
+          <p:cNvPr id="44" name="Connector 43"/>
           <p:cNvCxnSpPr/>
           <p:nvPr/>
         </p:nvCxnSpPr>
@@ -7362,7 +7467,7 @@
       </p:cxnSp>
       <p:cxnSp>
         <p:nvCxnSpPr>
-          <p:cNvPr id="43" name="Connector 42"/>
+          <p:cNvPr id="45" name="Connector 44"/>
           <p:cNvCxnSpPr/>
           <p:nvPr/>
         </p:nvCxnSpPr>
@@ -7399,7 +7504,7 @@
       </p:cxnSp>
       <p:sp>
         <p:nvSpPr>
-          <p:cNvPr id="44" name="Oval 43"/>
+          <p:cNvPr id="46" name="Oval 45"/>
           <p:cNvSpPr/>
           <p:nvPr/>
         </p:nvSpPr>
@@ -7441,7 +7546,7 @@
       </p:sp>
       <p:cxnSp>
         <p:nvCxnSpPr>
-          <p:cNvPr id="45" name="Connector 44"/>
+          <p:cNvPr id="47" name="Connector 46"/>
           <p:cNvCxnSpPr/>
           <p:nvPr/>
         </p:nvCxnSpPr>
@@ -7477,7 +7582,7 @@
       </p:cxnSp>
       <p:sp>
         <p:nvSpPr>
-          <p:cNvPr id="46" name="Oval 45"/>
+          <p:cNvPr id="48" name="Oval 47"/>
           <p:cNvSpPr/>
           <p:nvPr/>
         </p:nvSpPr>
@@ -7519,7 +7624,7 @@
       </p:sp>
       <p:cxnSp>
         <p:nvCxnSpPr>
-          <p:cNvPr id="47" name="Connector 46"/>
+          <p:cNvPr id="49" name="Connector 48"/>
           <p:cNvCxnSpPr/>
           <p:nvPr/>
         </p:nvCxnSpPr>
@@ -7556,7 +7661,7 @@
       </p:cxnSp>
       <p:cxnSp>
         <p:nvCxnSpPr>
-          <p:cNvPr id="48" name="Connector 47"/>
+          <p:cNvPr id="50" name="Connector 49"/>
           <p:cNvCxnSpPr/>
           <p:nvPr/>
         </p:nvCxnSpPr>
@@ -7593,7 +7698,7 @@
       </p:cxnSp>
       <p:sp>
         <p:nvSpPr>
-          <p:cNvPr id="49" name="TextBox 48"/>
+          <p:cNvPr id="51" name="TextBox 50"/>
           <p:cNvSpPr txBox="1"/>
           <p:nvPr/>
         </p:nvSpPr>
@@ -7635,7 +7740,7 @@
       </p:sp>
       <p:sp>
         <p:nvSpPr>
-          <p:cNvPr id="50" name="TextBox 49"/>
+          <p:cNvPr id="52" name="TextBox 51"/>
           <p:cNvSpPr txBox="1"/>
           <p:nvPr/>
         </p:nvSpPr>

</xml_diff>